<commit_message>
Update presentation title, add gitignore, and generate HTML project report
</commit_message>
<xml_diff>
--- a/project_presentation.pptx
+++ b/project_presentation.pptx
@@ -18225,7 +18225,7 @@
                 <a:cs typeface="Arial"/>
                 <a:sym typeface="Arial"/>
               </a:rPr>
-              <a:t>Domain of  Project – </a:t>
+              <a:t>Domain of Project – Healthcare</a:t>
             </a:r>
             <a:r>
               <a:rPr b="1" i="0" lang="en-US" sz="2400" u="none" cap="none" strike="noStrike">
@@ -18240,7 +18240,7 @@
                 <a:cs typeface="Arial"/>
                 <a:sym typeface="Arial"/>
               </a:rPr>
-              <a:t>[ like Agriculture / Education / Healthcare / … ]</a:t>
+              <a:t/>
             </a:r>
             <a:endParaRPr b="1" i="0" sz="2400" u="none" cap="none" strike="noStrike">
               <a:solidFill>
@@ -18304,7 +18304,7 @@
                 <a:cs typeface="Arial"/>
                 <a:sym typeface="Arial"/>
               </a:rPr>
-              <a:t>Project Tile – </a:t>
+              <a:t>Project Title – SmartBite: Personalized AI Nutrition Agent</a:t>
             </a:r>
             <a:r>
               <a:rPr b="1" i="0" lang="en-US" sz="2400" u="none" cap="none" strike="noStrike">
@@ -18319,7 +18319,7 @@
                 <a:cs typeface="Arial"/>
                 <a:sym typeface="Arial"/>
               </a:rPr>
-              <a:t>[</a:t>
+              <a:t/>
             </a:r>
             <a:r>
               <a:rPr b="1" i="0" lang="en-US" sz="2400" u="none" cap="none" strike="noStrike">
@@ -18334,7 +18334,7 @@
                 <a:cs typeface="Times New Roman"/>
                 <a:sym typeface="Times New Roman"/>
               </a:rPr>
-              <a:t>Write your project title here</a:t>
+              <a:t/>
             </a:r>
             <a:r>
               <a:rPr b="1" i="0" lang="en-US" sz="2400" u="none" cap="none" strike="noStrike">
@@ -18349,7 +18349,7 @@
                 <a:cs typeface="Arial"/>
                 <a:sym typeface="Arial"/>
               </a:rPr>
-              <a:t>]</a:t>
+              <a:t/>
             </a:r>
             <a:endParaRPr b="1" i="0" sz="2400" u="none" cap="none" strike="noStrike">
               <a:solidFill>

</xml_diff>